<commit_message>
Reformat literature survey as full IEEE-style numbered citations
Replaces the compact 3-column table (author/year/one-line contribution)
with full formal citations -- authors, title, venue, and page numbers
where the venue actually publishes them. Every author list, venue, and
page range was verified via WebFetch against ACL Anthology / NeurIPS
Proceedings directly (Niu ACL: 10862-10878, Es EACL: 150-158, Shuster
EMNLP Findings: 3784-3803); NeurIPS papers correctly omit page numbers
since that venue doesn't paginate, rather than guessing a range.
</commit_message>
<xml_diff>
--- a/presentation/Proposed_Solution_and_50_Percent_Completion.pptx
+++ b/presentation/Proposed_Solution_and_50_Percent_Completion.pptx
@@ -6521,784 +6521,335 @@
           </a:fontRef>
         </p:style>
       </p:cxnSp>
-      <p:graphicFrame>
-        <p:nvGraphicFramePr>
-          <p:cNvPr id="6" name="Table 5"/>
-          <p:cNvGraphicFramePr>
-            <a:graphicFrameLocks noGrp="1"/>
-          </p:cNvGraphicFramePr>
-          <p:nvPr/>
-        </p:nvGraphicFramePr>
-        <p:xfrm>
-          <a:off x="548640" y="1874519"/>
-          <a:ext cx="11064240" cy="3977639"/>
-        </p:xfrm>
-        <a:graphic>
-          <a:graphicData uri="http://schemas.openxmlformats.org/drawingml/2006/table">
-            <a:tbl>
-              <a:tblPr firstRow="1" bandRow="1">
-                <a:tableStyleId>{5C22544A-7EE6-4342-B048-85BDC9FD1C3A}</a:tableStyleId>
-              </a:tblPr>
-              <a:tblGrid>
-                <a:gridCol w="457200"/>
-                <a:gridCol w="3383280"/>
-                <a:gridCol w="7223760"/>
-              </a:tblGrid>
-              <a:tr h="361603">
-                <a:tc>
-                  <a:txBody>
-                    <a:bodyPr/>
-                    <a:lstStyle/>
-                    <a:p>
-                      <a:r>
-                        <a:rPr sz="1200" b="1">
-                          <a:solidFill>
-                            <a:srgbClr val="FFFFFF"/>
-                          </a:solidFill>
-                          <a:latin typeface="Segoe UI"/>
-                        </a:rPr>
-                        <a:t>#</a:t>
-                      </a:r>
-                    </a:p>
-                  </a:txBody>
-                  <a:tcPr anchor="ctr" marL="109728">
-                    <a:solidFill>
-                      <a:srgbClr val="0D3B66"/>
-                    </a:solidFill>
-                  </a:tcPr>
-                </a:tc>
-                <a:tc>
-                  <a:txBody>
-                    <a:bodyPr/>
-                    <a:lstStyle/>
-                    <a:p>
-                      <a:r>
-                        <a:rPr sz="1200" b="1">
-                          <a:solidFill>
-                            <a:srgbClr val="FFFFFF"/>
-                          </a:solidFill>
-                          <a:latin typeface="Segoe UI"/>
-                        </a:rPr>
-                        <a:t>Reference</a:t>
-                      </a:r>
-                    </a:p>
-                  </a:txBody>
-                  <a:tcPr anchor="ctr" marL="109728">
-                    <a:solidFill>
-                      <a:srgbClr val="0D3B66"/>
-                    </a:solidFill>
-                  </a:tcPr>
-                </a:tc>
-                <a:tc>
-                  <a:txBody>
-                    <a:bodyPr/>
-                    <a:lstStyle/>
-                    <a:p>
-                      <a:r>
-                        <a:rPr sz="1200" b="1">
-                          <a:solidFill>
-                            <a:srgbClr val="FFFFFF"/>
-                          </a:solidFill>
-                          <a:latin typeface="Segoe UI"/>
-                        </a:rPr>
-                        <a:t>Key Contribution</a:t>
-                      </a:r>
-                    </a:p>
-                  </a:txBody>
-                  <a:tcPr anchor="ctr" marL="109728">
-                    <a:solidFill>
-                      <a:srgbClr val="0D3B66"/>
-                    </a:solidFill>
-                  </a:tcPr>
-                </a:tc>
-              </a:tr>
-              <a:tr h="361603">
-                <a:tc>
-                  <a:txBody>
-                    <a:bodyPr/>
-                    <a:lstStyle/>
-                    <a:p>
-                      <a:r>
-                        <a:rPr sz="1100" b="1">
-                          <a:solidFill>
-                            <a:srgbClr val="1A1D22"/>
-                          </a:solidFill>
-                          <a:latin typeface="Segoe UI"/>
-                        </a:rPr>
-                        <a:t>1</a:t>
-                      </a:r>
-                    </a:p>
-                  </a:txBody>
-                  <a:tcPr anchor="ctr" marL="109728" marT="27432" marB="27432">
-                    <a:solidFill>
-                      <a:srgbClr val="FFFFFF"/>
-                    </a:solidFill>
-                  </a:tcPr>
-                </a:tc>
-                <a:tc>
-                  <a:txBody>
-                    <a:bodyPr/>
-                    <a:lstStyle/>
-                    <a:p>
-                      <a:r>
-                        <a:rPr sz="1100" b="0">
-                          <a:solidFill>
-                            <a:srgbClr val="4A4F58"/>
-                          </a:solidFill>
-                          <a:latin typeface="Segoe UI"/>
-                        </a:rPr>
-                        <a:t>Lewis et al. (2020, NeurIPS)</a:t>
-                      </a:r>
-                    </a:p>
-                  </a:txBody>
-                  <a:tcPr anchor="ctr" marL="109728" marT="27432" marB="27432">
-                    <a:solidFill>
-                      <a:srgbClr val="FFFFFF"/>
-                    </a:solidFill>
-                  </a:tcPr>
-                </a:tc>
-                <a:tc>
-                  <a:txBody>
-                    <a:bodyPr/>
-                    <a:lstStyle/>
-                    <a:p>
-                      <a:r>
-                        <a:rPr sz="1100" b="0">
-                          <a:solidFill>
-                            <a:srgbClr val="4A4F58"/>
-                          </a:solidFill>
-                          <a:latin typeface="Segoe UI"/>
-                        </a:rPr>
-                        <a:t>Introduced Retrieval-Augmented Generation (RAG)</a:t>
-                      </a:r>
-                    </a:p>
-                  </a:txBody>
-                  <a:tcPr anchor="ctr" marL="109728" marT="27432" marB="27432">
-                    <a:solidFill>
-                      <a:srgbClr val="FFFFFF"/>
-                    </a:solidFill>
-                  </a:tcPr>
-                </a:tc>
-              </a:tr>
-              <a:tr h="361603">
-                <a:tc>
-                  <a:txBody>
-                    <a:bodyPr/>
-                    <a:lstStyle/>
-                    <a:p>
-                      <a:r>
-                        <a:rPr sz="1100" b="1">
-                          <a:solidFill>
-                            <a:srgbClr val="1A1D22"/>
-                          </a:solidFill>
-                          <a:latin typeface="Segoe UI"/>
-                        </a:rPr>
-                        <a:t>2</a:t>
-                      </a:r>
-                    </a:p>
-                  </a:txBody>
-                  <a:tcPr anchor="ctr" marL="109728" marT="27432" marB="27432">
-                    <a:solidFill>
-                      <a:srgbClr val="F7F9FA"/>
-                    </a:solidFill>
-                  </a:tcPr>
-                </a:tc>
-                <a:tc>
-                  <a:txBody>
-                    <a:bodyPr/>
-                    <a:lstStyle/>
-                    <a:p>
-                      <a:r>
-                        <a:rPr sz="1100" b="0">
-                          <a:solidFill>
-                            <a:srgbClr val="4A4F58"/>
-                          </a:solidFill>
-                          <a:latin typeface="Segoe UI"/>
-                        </a:rPr>
-                        <a:t>Brown et al. (2020, NeurIPS)</a:t>
-                      </a:r>
-                    </a:p>
-                  </a:txBody>
-                  <a:tcPr anchor="ctr" marL="109728" marT="27432" marB="27432">
-                    <a:solidFill>
-                      <a:srgbClr val="F7F9FA"/>
-                    </a:solidFill>
-                  </a:tcPr>
-                </a:tc>
-                <a:tc>
-                  <a:txBody>
-                    <a:bodyPr/>
-                    <a:lstStyle/>
-                    <a:p>
-                      <a:r>
-                        <a:rPr sz="1100" b="0">
-                          <a:solidFill>
-                            <a:srgbClr val="4A4F58"/>
-                          </a:solidFill>
-                          <a:latin typeface="Segoe UI"/>
-                        </a:rPr>
-                        <a:t>GPT-3; established few-shot in-context learning</a:t>
-                      </a:r>
-                    </a:p>
-                  </a:txBody>
-                  <a:tcPr anchor="ctr" marL="109728" marT="27432" marB="27432">
-                    <a:solidFill>
-                      <a:srgbClr val="F7F9FA"/>
-                    </a:solidFill>
-                  </a:tcPr>
-                </a:tc>
-              </a:tr>
-              <a:tr h="361603">
-                <a:tc>
-                  <a:txBody>
-                    <a:bodyPr/>
-                    <a:lstStyle/>
-                    <a:p>
-                      <a:r>
-                        <a:rPr sz="1100" b="1">
-                          <a:solidFill>
-                            <a:srgbClr val="1A1D22"/>
-                          </a:solidFill>
-                          <a:latin typeface="Segoe UI"/>
-                        </a:rPr>
-                        <a:t>3</a:t>
-                      </a:r>
-                    </a:p>
-                  </a:txBody>
-                  <a:tcPr anchor="ctr" marL="109728" marT="27432" marB="27432">
-                    <a:solidFill>
-                      <a:srgbClr val="FFFFFF"/>
-                    </a:solidFill>
-                  </a:tcPr>
-                </a:tc>
-                <a:tc>
-                  <a:txBody>
-                    <a:bodyPr/>
-                    <a:lstStyle/>
-                    <a:p>
-                      <a:r>
-                        <a:rPr sz="1100" b="0">
-                          <a:solidFill>
-                            <a:srgbClr val="4A4F58"/>
-                          </a:solidFill>
-                          <a:latin typeface="Segoe UI"/>
-                        </a:rPr>
-                        <a:t>Shuster et al. (2021, EMNLP Findings)</a:t>
-                      </a:r>
-                    </a:p>
-                  </a:txBody>
-                  <a:tcPr anchor="ctr" marL="109728" marT="27432" marB="27432">
-                    <a:solidFill>
-                      <a:srgbClr val="FFFFFF"/>
-                    </a:solidFill>
-                  </a:tcPr>
-                </a:tc>
-                <a:tc>
-                  <a:txBody>
-                    <a:bodyPr/>
-                    <a:lstStyle/>
-                    <a:p>
-                      <a:r>
-                        <a:rPr sz="1100" b="0">
-                          <a:solidFill>
-                            <a:srgbClr val="4A4F58"/>
-                          </a:solidFill>
-                          <a:latin typeface="Segoe UI"/>
-                        </a:rPr>
-                        <a:t>Retrieval augmentation reduces hallucination in dialogue</a:t>
-                      </a:r>
-                    </a:p>
-                  </a:txBody>
-                  <a:tcPr anchor="ctr" marL="109728" marT="27432" marB="27432">
-                    <a:solidFill>
-                      <a:srgbClr val="FFFFFF"/>
-                    </a:solidFill>
-                  </a:tcPr>
-                </a:tc>
-              </a:tr>
-              <a:tr h="361603">
-                <a:tc>
-                  <a:txBody>
-                    <a:bodyPr/>
-                    <a:lstStyle/>
-                    <a:p>
-                      <a:r>
-                        <a:rPr sz="1100" b="1">
-                          <a:solidFill>
-                            <a:srgbClr val="1A1D22"/>
-                          </a:solidFill>
-                          <a:latin typeface="Segoe UI"/>
-                        </a:rPr>
-                        <a:t>4</a:t>
-                      </a:r>
-                    </a:p>
-                  </a:txBody>
-                  <a:tcPr anchor="ctr" marL="109728" marT="27432" marB="27432">
-                    <a:solidFill>
-                      <a:srgbClr val="F7F9FA"/>
-                    </a:solidFill>
-                  </a:tcPr>
-                </a:tc>
-                <a:tc>
-                  <a:txBody>
-                    <a:bodyPr/>
-                    <a:lstStyle/>
-                    <a:p>
-                      <a:r>
-                        <a:rPr sz="1100" b="0">
-                          <a:solidFill>
-                            <a:srgbClr val="4A4F58"/>
-                          </a:solidFill>
-                          <a:latin typeface="Segoe UI"/>
-                        </a:rPr>
-                        <a:t>Wei et al. (2022, NeurIPS)</a:t>
-                      </a:r>
-                    </a:p>
-                  </a:txBody>
-                  <a:tcPr anchor="ctr" marL="109728" marT="27432" marB="27432">
-                    <a:solidFill>
-                      <a:srgbClr val="F7F9FA"/>
-                    </a:solidFill>
-                  </a:tcPr>
-                </a:tc>
-                <a:tc>
-                  <a:txBody>
-                    <a:bodyPr/>
-                    <a:lstStyle/>
-                    <a:p>
-                      <a:r>
-                        <a:rPr sz="1100" b="0">
-                          <a:solidFill>
-                            <a:srgbClr val="4A4F58"/>
-                          </a:solidFill>
-                          <a:latin typeface="Segoe UI"/>
-                        </a:rPr>
-                        <a:t>Chain-of-Thought prompting improves multi-step reasoning</a:t>
-                      </a:r>
-                    </a:p>
-                  </a:txBody>
-                  <a:tcPr anchor="ctr" marL="109728" marT="27432" marB="27432">
-                    <a:solidFill>
-                      <a:srgbClr val="F7F9FA"/>
-                    </a:solidFill>
-                  </a:tcPr>
-                </a:tc>
-              </a:tr>
-              <a:tr h="361603">
-                <a:tc>
-                  <a:txBody>
-                    <a:bodyPr/>
-                    <a:lstStyle/>
-                    <a:p>
-                      <a:r>
-                        <a:rPr sz="1100" b="1">
-                          <a:solidFill>
-                            <a:srgbClr val="1A1D22"/>
-                          </a:solidFill>
-                          <a:latin typeface="Segoe UI"/>
-                        </a:rPr>
-                        <a:t>5</a:t>
-                      </a:r>
-                    </a:p>
-                  </a:txBody>
-                  <a:tcPr anchor="ctr" marL="109728" marT="27432" marB="27432">
-                    <a:solidFill>
-                      <a:srgbClr val="FFFFFF"/>
-                    </a:solidFill>
-                  </a:tcPr>
-                </a:tc>
-                <a:tc>
-                  <a:txBody>
-                    <a:bodyPr/>
-                    <a:lstStyle/>
-                    <a:p>
-                      <a:r>
-                        <a:rPr sz="1100" b="0">
-                          <a:solidFill>
-                            <a:srgbClr val="4A4F58"/>
-                          </a:solidFill>
-                          <a:latin typeface="Segoe UI"/>
-                        </a:rPr>
-                        <a:t>Kojima et al. (2022, NeurIPS)</a:t>
-                      </a:r>
-                    </a:p>
-                  </a:txBody>
-                  <a:tcPr anchor="ctr" marL="109728" marT="27432" marB="27432">
-                    <a:solidFill>
-                      <a:srgbClr val="FFFFFF"/>
-                    </a:solidFill>
-                  </a:tcPr>
-                </a:tc>
-                <a:tc>
-                  <a:txBody>
-                    <a:bodyPr/>
-                    <a:lstStyle/>
-                    <a:p>
-                      <a:r>
-                        <a:rPr sz="1100" b="0">
-                          <a:solidFill>
-                            <a:srgbClr val="4A4F58"/>
-                          </a:solidFill>
-                          <a:latin typeface="Segoe UI"/>
-                        </a:rPr>
-                        <a:t>Zero-shot CoT via “Let’s think step by step”</a:t>
-                      </a:r>
-                    </a:p>
-                  </a:txBody>
-                  <a:tcPr anchor="ctr" marL="109728" marT="27432" marB="27432">
-                    <a:solidFill>
-                      <a:srgbClr val="FFFFFF"/>
-                    </a:solidFill>
-                  </a:tcPr>
-                </a:tc>
-              </a:tr>
-              <a:tr h="361603">
-                <a:tc>
-                  <a:txBody>
-                    <a:bodyPr/>
-                    <a:lstStyle/>
-                    <a:p>
-                      <a:r>
-                        <a:rPr sz="1100" b="1">
-                          <a:solidFill>
-                            <a:srgbClr val="1A1D22"/>
-                          </a:solidFill>
-                          <a:latin typeface="Segoe UI"/>
-                        </a:rPr>
-                        <a:t>6</a:t>
-                      </a:r>
-                    </a:p>
-                  </a:txBody>
-                  <a:tcPr anchor="ctr" marL="109728" marT="27432" marB="27432">
-                    <a:solidFill>
-                      <a:srgbClr val="F7F9FA"/>
-                    </a:solidFill>
-                  </a:tcPr>
-                </a:tc>
-                <a:tc>
-                  <a:txBody>
-                    <a:bodyPr/>
-                    <a:lstStyle/>
-                    <a:p>
-                      <a:r>
-                        <a:rPr sz="1100" b="0">
-                          <a:solidFill>
-                            <a:srgbClr val="4A4F58"/>
-                          </a:solidFill>
-                          <a:latin typeface="Segoe UI"/>
-                        </a:rPr>
-                        <a:t>Liu et al. (2023, ACM Comput. Surv.)</a:t>
-                      </a:r>
-                    </a:p>
-                  </a:txBody>
-                  <a:tcPr anchor="ctr" marL="109728" marT="27432" marB="27432">
-                    <a:solidFill>
-                      <a:srgbClr val="F7F9FA"/>
-                    </a:solidFill>
-                  </a:tcPr>
-                </a:tc>
-                <a:tc>
-                  <a:txBody>
-                    <a:bodyPr/>
-                    <a:lstStyle/>
-                    <a:p>
-                      <a:r>
-                        <a:rPr sz="1100" b="0">
-                          <a:solidFill>
-                            <a:srgbClr val="4A4F58"/>
-                          </a:solidFill>
-                          <a:latin typeface="Segoe UI"/>
-                        </a:rPr>
-                        <a:t>Systematic survey of prompting methods in NLP</a:t>
-                      </a:r>
-                    </a:p>
-                  </a:txBody>
-                  <a:tcPr anchor="ctr" marL="109728" marT="27432" marB="27432">
-                    <a:solidFill>
-                      <a:srgbClr val="F7F9FA"/>
-                    </a:solidFill>
-                  </a:tcPr>
-                </a:tc>
-              </a:tr>
-              <a:tr h="361603">
-                <a:tc>
-                  <a:txBody>
-                    <a:bodyPr/>
-                    <a:lstStyle/>
-                    <a:p>
-                      <a:r>
-                        <a:rPr sz="1100" b="1">
-                          <a:solidFill>
-                            <a:srgbClr val="1A1D22"/>
-                          </a:solidFill>
-                          <a:latin typeface="Segoe UI"/>
-                        </a:rPr>
-                        <a:t>7</a:t>
-                      </a:r>
-                    </a:p>
-                  </a:txBody>
-                  <a:tcPr anchor="ctr" marL="109728" marT="27432" marB="27432">
-                    <a:solidFill>
-                      <a:srgbClr val="FFFFFF"/>
-                    </a:solidFill>
-                  </a:tcPr>
-                </a:tc>
-                <a:tc>
-                  <a:txBody>
-                    <a:bodyPr/>
-                    <a:lstStyle/>
-                    <a:p>
-                      <a:r>
-                        <a:rPr sz="1100" b="0">
-                          <a:solidFill>
-                            <a:srgbClr val="4A4F58"/>
-                          </a:solidFill>
-                          <a:latin typeface="Segoe UI"/>
-                        </a:rPr>
-                        <a:t>Ji et al. (2023, ACM Comput. Surv.)</a:t>
-                      </a:r>
-                    </a:p>
-                  </a:txBody>
-                  <a:tcPr anchor="ctr" marL="109728" marT="27432" marB="27432">
-                    <a:solidFill>
-                      <a:srgbClr val="FFFFFF"/>
-                    </a:solidFill>
-                  </a:tcPr>
-                </a:tc>
-                <a:tc>
-                  <a:txBody>
-                    <a:bodyPr/>
-                    <a:lstStyle/>
-                    <a:p>
-                      <a:r>
-                        <a:rPr sz="1100" b="0">
-                          <a:solidFill>
-                            <a:srgbClr val="4A4F58"/>
-                          </a:solidFill>
-                          <a:latin typeface="Segoe UI"/>
-                        </a:rPr>
-                        <a:t>Survey of hallucination in natural language generation</a:t>
-                      </a:r>
-                    </a:p>
-                  </a:txBody>
-                  <a:tcPr anchor="ctr" marL="109728" marT="27432" marB="27432">
-                    <a:solidFill>
-                      <a:srgbClr val="FFFFFF"/>
-                    </a:solidFill>
-                  </a:tcPr>
-                </a:tc>
-              </a:tr>
-              <a:tr h="361603">
-                <a:tc>
-                  <a:txBody>
-                    <a:bodyPr/>
-                    <a:lstStyle/>
-                    <a:p>
-                      <a:r>
-                        <a:rPr sz="1100" b="1">
-                          <a:solidFill>
-                            <a:srgbClr val="1A1D22"/>
-                          </a:solidFill>
-                          <a:latin typeface="Segoe UI"/>
-                        </a:rPr>
-                        <a:t>8</a:t>
-                      </a:r>
-                    </a:p>
-                  </a:txBody>
-                  <a:tcPr anchor="ctr" marL="109728" marT="27432" marB="27432">
-                    <a:solidFill>
-                      <a:srgbClr val="F7F9FA"/>
-                    </a:solidFill>
-                  </a:tcPr>
-                </a:tc>
-                <a:tc>
-                  <a:txBody>
-                    <a:bodyPr/>
-                    <a:lstStyle/>
-                    <a:p>
-                      <a:r>
-                        <a:rPr sz="1100" b="0">
-                          <a:solidFill>
-                            <a:srgbClr val="4A4F58"/>
-                          </a:solidFill>
-                          <a:latin typeface="Segoe UI"/>
-                        </a:rPr>
-                        <a:t>Gao et al. (2023, arXiv survey)</a:t>
-                      </a:r>
-                    </a:p>
-                  </a:txBody>
-                  <a:tcPr anchor="ctr" marL="109728" marT="27432" marB="27432">
-                    <a:solidFill>
-                      <a:srgbClr val="F7F9FA"/>
-                    </a:solidFill>
-                  </a:tcPr>
-                </a:tc>
-                <a:tc>
-                  <a:txBody>
-                    <a:bodyPr/>
-                    <a:lstStyle/>
-                    <a:p>
-                      <a:r>
-                        <a:rPr sz="1100" b="0">
-                          <a:solidFill>
-                            <a:srgbClr val="4A4F58"/>
-                          </a:solidFill>
-                          <a:latin typeface="Segoe UI"/>
-                        </a:rPr>
-                        <a:t>Survey of RAG techniques for large language models</a:t>
-                      </a:r>
-                    </a:p>
-                  </a:txBody>
-                  <a:tcPr anchor="ctr" marL="109728" marT="27432" marB="27432">
-                    <a:solidFill>
-                      <a:srgbClr val="F7F9FA"/>
-                    </a:solidFill>
-                  </a:tcPr>
-                </a:tc>
-              </a:tr>
-              <a:tr h="361603">
-                <a:tc>
-                  <a:txBody>
-                    <a:bodyPr/>
-                    <a:lstStyle/>
-                    <a:p>
-                      <a:r>
-                        <a:rPr sz="1100" b="1">
-                          <a:solidFill>
-                            <a:srgbClr val="1A1D22"/>
-                          </a:solidFill>
-                          <a:latin typeface="Segoe UI"/>
-                        </a:rPr>
-                        <a:t>9</a:t>
-                      </a:r>
-                    </a:p>
-                  </a:txBody>
-                  <a:tcPr anchor="ctr" marL="109728" marT="27432" marB="27432">
-                    <a:solidFill>
-                      <a:srgbClr val="FFFFFF"/>
-                    </a:solidFill>
-                  </a:tcPr>
-                </a:tc>
-                <a:tc>
-                  <a:txBody>
-                    <a:bodyPr/>
-                    <a:lstStyle/>
-                    <a:p>
-                      <a:r>
-                        <a:rPr sz="1100" b="0">
-                          <a:solidFill>
-                            <a:srgbClr val="4A4F58"/>
-                          </a:solidFill>
-                          <a:latin typeface="Segoe UI"/>
-                        </a:rPr>
-                        <a:t>Es et al. (2024, EACL)</a:t>
-                      </a:r>
-                    </a:p>
-                  </a:txBody>
-                  <a:tcPr anchor="ctr" marL="109728" marT="27432" marB="27432">
-                    <a:solidFill>
-                      <a:srgbClr val="FFFFFF"/>
-                    </a:solidFill>
-                  </a:tcPr>
-                </a:tc>
-                <a:tc>
-                  <a:txBody>
-                    <a:bodyPr/>
-                    <a:lstStyle/>
-                    <a:p>
-                      <a:r>
-                        <a:rPr sz="1100" b="0">
-                          <a:solidFill>
-                            <a:srgbClr val="4A4F58"/>
-                          </a:solidFill>
-                          <a:latin typeface="Segoe UI"/>
-                        </a:rPr>
-                        <a:t>RAGAS: reference-free evaluation metrics for RAG</a:t>
-                      </a:r>
-                    </a:p>
-                  </a:txBody>
-                  <a:tcPr anchor="ctr" marL="109728" marT="27432" marB="27432">
-                    <a:solidFill>
-                      <a:srgbClr val="FFFFFF"/>
-                    </a:solidFill>
-                  </a:tcPr>
-                </a:tc>
-              </a:tr>
-              <a:tr h="361609">
-                <a:tc>
-                  <a:txBody>
-                    <a:bodyPr/>
-                    <a:lstStyle/>
-                    <a:p>
-                      <a:r>
-                        <a:rPr sz="1100" b="1">
-                          <a:solidFill>
-                            <a:srgbClr val="1A1D22"/>
-                          </a:solidFill>
-                          <a:latin typeface="Segoe UI"/>
-                        </a:rPr>
-                        <a:t>10</a:t>
-                      </a:r>
-                    </a:p>
-                  </a:txBody>
-                  <a:tcPr anchor="ctr" marL="109728" marT="27432" marB="27432">
-                    <a:solidFill>
-                      <a:srgbClr val="F7F9FA"/>
-                    </a:solidFill>
-                  </a:tcPr>
-                </a:tc>
-                <a:tc>
-                  <a:txBody>
-                    <a:bodyPr/>
-                    <a:lstStyle/>
-                    <a:p>
-                      <a:r>
-                        <a:rPr sz="1100" b="0">
-                          <a:solidFill>
-                            <a:srgbClr val="4A4F58"/>
-                          </a:solidFill>
-                          <a:latin typeface="Segoe UI"/>
-                        </a:rPr>
-                        <a:t>Niu et al. (2024, ACL)</a:t>
-                      </a:r>
-                    </a:p>
-                  </a:txBody>
-                  <a:tcPr anchor="ctr" marL="109728" marT="27432" marB="27432">
-                    <a:solidFill>
-                      <a:srgbClr val="F7F9FA"/>
-                    </a:solidFill>
-                  </a:tcPr>
-                </a:tc>
-                <a:tc>
-                  <a:txBody>
-                    <a:bodyPr/>
-                    <a:lstStyle/>
-                    <a:p>
-                      <a:r>
-                        <a:rPr sz="1100" b="0">
-                          <a:solidFill>
-                            <a:srgbClr val="4A4F58"/>
-                          </a:solidFill>
-                          <a:latin typeface="Segoe UI"/>
-                        </a:rPr>
-                        <a:t>RAGTruth: hallucination corpus used as this project’s dataset</a:t>
-                      </a:r>
-                    </a:p>
-                  </a:txBody>
-                  <a:tcPr anchor="ctr" marL="109728" marT="27432" marB="27432">
-                    <a:solidFill>
-                      <a:srgbClr val="F7F9FA"/>
-                    </a:solidFill>
-                  </a:tcPr>
-                </a:tc>
-              </a:tr>
-            </a:tbl>
-          </a:graphicData>
-        </a:graphic>
-      </p:graphicFrame>
-      <p:sp>
-        <p:nvSpPr>
-          <p:cNvPr id="7" name="Rectangle 6"/>
+      <p:sp>
+        <p:nvSpPr>
+          <p:cNvPr id="6" name="TextBox 5"/>
+          <p:cNvSpPr txBox="1"/>
+          <p:nvPr/>
+        </p:nvSpPr>
+        <p:spPr>
+          <a:xfrm>
+            <a:off x="548640" y="1874519"/>
+            <a:ext cx="5349240" cy="4297680"/>
+          </a:xfrm>
+          <a:prstGeom prst="rect">
+            <a:avLst/>
+          </a:prstGeom>
+          <a:noFill/>
+        </p:spPr>
+        <p:txBody>
+          <a:bodyPr wrap="square" lIns="0" rIns="0" tIns="0" bIns="0">
+            <a:spAutoFit/>
+          </a:bodyPr>
+          <a:lstStyle/>
+          <a:p>
+            <a:pPr>
+              <a:lnSpc>
+                <a:spcPct val="105000"/>
+              </a:lnSpc>
+              <a:spcAft>
+                <a:spcPts val="1000"/>
+              </a:spcAft>
+            </a:pPr>
+            <a:r>
+              <a:rPr sz="1050" b="1">
+                <a:solidFill>
+                  <a:srgbClr val="0D3B66"/>
+                </a:solidFill>
+                <a:latin typeface="Consolas"/>
+              </a:rPr>
+              <a:t>[1]  </a:t>
+            </a:r>
+            <a:r>
+              <a:rPr sz="1050">
+                <a:solidFill>
+                  <a:srgbClr val="4A4F58"/>
+                </a:solidFill>
+                <a:latin typeface="Segoe UI"/>
+              </a:rPr>
+              <a:t>P. Lewis et al., “Retrieval-augmented generation for knowledge-intensive NLP tasks,” in Advances in Neural Information Processing Systems 33 (NeurIPS 2020), 2020.</a:t>
+            </a:r>
+          </a:p>
+          <a:p>
+            <a:pPr>
+              <a:lnSpc>
+                <a:spcPct val="105000"/>
+              </a:lnSpc>
+              <a:spcAft>
+                <a:spcPts val="1000"/>
+              </a:spcAft>
+            </a:pPr>
+            <a:r>
+              <a:rPr sz="1050" b="1">
+                <a:solidFill>
+                  <a:srgbClr val="0D3B66"/>
+                </a:solidFill>
+                <a:latin typeface="Consolas"/>
+              </a:rPr>
+              <a:t>[2]  </a:t>
+            </a:r>
+            <a:r>
+              <a:rPr sz="1050">
+                <a:solidFill>
+                  <a:srgbClr val="4A4F58"/>
+                </a:solidFill>
+                <a:latin typeface="Segoe UI"/>
+              </a:rPr>
+              <a:t>T. B. Brown et al., “Language models are few-shot learners,” in Advances in Neural Information Processing Systems 33 (NeurIPS 2020), 2020.</a:t>
+            </a:r>
+          </a:p>
+          <a:p>
+            <a:pPr>
+              <a:lnSpc>
+                <a:spcPct val="105000"/>
+              </a:lnSpc>
+              <a:spcAft>
+                <a:spcPts val="1000"/>
+              </a:spcAft>
+            </a:pPr>
+            <a:r>
+              <a:rPr sz="1050" b="1">
+                <a:solidFill>
+                  <a:srgbClr val="0D3B66"/>
+                </a:solidFill>
+                <a:latin typeface="Consolas"/>
+              </a:rPr>
+              <a:t>[3]  </a:t>
+            </a:r>
+            <a:r>
+              <a:rPr sz="1050">
+                <a:solidFill>
+                  <a:srgbClr val="4A4F58"/>
+                </a:solidFill>
+                <a:latin typeface="Segoe UI"/>
+              </a:rPr>
+              <a:t>K. Shuster, S. Poff, M. Chen, D. Kiela, and J. Weston, “Retrieval augmentation reduces hallucination in conversation,” in Findings of the Association for Computational Linguistics: EMNLP 2021, Punta Cana, Dominican Republic, Nov. 2021, pp. 3784–3803.</a:t>
+            </a:r>
+          </a:p>
+          <a:p>
+            <a:pPr>
+              <a:lnSpc>
+                <a:spcPct val="105000"/>
+              </a:lnSpc>
+              <a:spcAft>
+                <a:spcPts val="1000"/>
+              </a:spcAft>
+            </a:pPr>
+            <a:r>
+              <a:rPr sz="1050" b="1">
+                <a:solidFill>
+                  <a:srgbClr val="0D3B66"/>
+                </a:solidFill>
+                <a:latin typeface="Consolas"/>
+              </a:rPr>
+              <a:t>[4]  </a:t>
+            </a:r>
+            <a:r>
+              <a:rPr sz="1050">
+                <a:solidFill>
+                  <a:srgbClr val="4A4F58"/>
+                </a:solidFill>
+                <a:latin typeface="Segoe UI"/>
+              </a:rPr>
+              <a:t>J. Wei et al., “Chain-of-thought prompting elicits reasoning in large language models,” in Advances in Neural Information Processing Systems 35 (NeurIPS 2022), 2022.</a:t>
+            </a:r>
+          </a:p>
+          <a:p>
+            <a:pPr>
+              <a:lnSpc>
+                <a:spcPct val="105000"/>
+              </a:lnSpc>
+              <a:spcAft>
+                <a:spcPts val="1000"/>
+              </a:spcAft>
+            </a:pPr>
+            <a:r>
+              <a:rPr sz="1050" b="1">
+                <a:solidFill>
+                  <a:srgbClr val="0D3B66"/>
+                </a:solidFill>
+                <a:latin typeface="Consolas"/>
+              </a:rPr>
+              <a:t>[5]  </a:t>
+            </a:r>
+            <a:r>
+              <a:rPr sz="1050">
+                <a:solidFill>
+                  <a:srgbClr val="4A4F58"/>
+                </a:solidFill>
+                <a:latin typeface="Segoe UI"/>
+              </a:rPr>
+              <a:t>T. Kojima, S. S. Gu, M. Reid, Y. Matsuo, and Y. Iwasawa, “Large language models are zero-shot reasoners,” in Advances in Neural Information Processing Systems 35 (NeurIPS 2022), 2022.</a:t>
+            </a:r>
+          </a:p>
+        </p:txBody>
+      </p:sp>
+      <p:sp>
+        <p:nvSpPr>
+          <p:cNvPr id="7" name="TextBox 6"/>
+          <p:cNvSpPr txBox="1"/>
+          <p:nvPr/>
+        </p:nvSpPr>
+        <p:spPr>
+          <a:xfrm>
+            <a:off x="6172200" y="1874519"/>
+            <a:ext cx="5349240" cy="4297680"/>
+          </a:xfrm>
+          <a:prstGeom prst="rect">
+            <a:avLst/>
+          </a:prstGeom>
+          <a:noFill/>
+        </p:spPr>
+        <p:txBody>
+          <a:bodyPr wrap="square" lIns="0" rIns="0" tIns="0" bIns="0">
+            <a:spAutoFit/>
+          </a:bodyPr>
+          <a:lstStyle/>
+          <a:p>
+            <a:pPr>
+              <a:lnSpc>
+                <a:spcPct val="105000"/>
+              </a:lnSpc>
+              <a:spcAft>
+                <a:spcPts val="1000"/>
+              </a:spcAft>
+            </a:pPr>
+            <a:r>
+              <a:rPr sz="1050" b="1">
+                <a:solidFill>
+                  <a:srgbClr val="0D3B66"/>
+                </a:solidFill>
+                <a:latin typeface="Consolas"/>
+              </a:rPr>
+              <a:t>[6]  </a:t>
+            </a:r>
+            <a:r>
+              <a:rPr sz="1050">
+                <a:solidFill>
+                  <a:srgbClr val="4A4F58"/>
+                </a:solidFill>
+                <a:latin typeface="Segoe UI"/>
+              </a:rPr>
+              <a:t>P. Liu, W. Yuan, J. Fu, Z. Jiang, H. Hayashi, and G. Neubig, “Pre-train, prompt, and predict: A systematic survey of prompting methods in natural language processing,” ACM Computing Surveys, vol. 55, no. 9, pp. 1–35, Jan. 2023.</a:t>
+            </a:r>
+          </a:p>
+          <a:p>
+            <a:pPr>
+              <a:lnSpc>
+                <a:spcPct val="105000"/>
+              </a:lnSpc>
+              <a:spcAft>
+                <a:spcPts val="1000"/>
+              </a:spcAft>
+            </a:pPr>
+            <a:r>
+              <a:rPr sz="1050" b="1">
+                <a:solidFill>
+                  <a:srgbClr val="0D3B66"/>
+                </a:solidFill>
+                <a:latin typeface="Consolas"/>
+              </a:rPr>
+              <a:t>[7]  </a:t>
+            </a:r>
+            <a:r>
+              <a:rPr sz="1050">
+                <a:solidFill>
+                  <a:srgbClr val="4A4F58"/>
+                </a:solidFill>
+                <a:latin typeface="Segoe UI"/>
+              </a:rPr>
+              <a:t>Z. Ji et al., “Survey of hallucination in natural language generation,” ACM Computing Surveys, vol. 55, no. 12, 2023.</a:t>
+            </a:r>
+          </a:p>
+          <a:p>
+            <a:pPr>
+              <a:lnSpc>
+                <a:spcPct val="105000"/>
+              </a:lnSpc>
+              <a:spcAft>
+                <a:spcPts val="1000"/>
+              </a:spcAft>
+            </a:pPr>
+            <a:r>
+              <a:rPr sz="1050" b="1">
+                <a:solidFill>
+                  <a:srgbClr val="0D3B66"/>
+                </a:solidFill>
+                <a:latin typeface="Consolas"/>
+              </a:rPr>
+              <a:t>[8]  </a:t>
+            </a:r>
+            <a:r>
+              <a:rPr sz="1050">
+                <a:solidFill>
+                  <a:srgbClr val="4A4F58"/>
+                </a:solidFill>
+                <a:latin typeface="Segoe UI"/>
+              </a:rPr>
+              <a:t>Y. Gao et al., “Retrieval-augmented generation for large language models: A survey,” arXiv preprint arXiv:2312.10997, Dec. 2023.</a:t>
+            </a:r>
+          </a:p>
+          <a:p>
+            <a:pPr>
+              <a:lnSpc>
+                <a:spcPct val="105000"/>
+              </a:lnSpc>
+              <a:spcAft>
+                <a:spcPts val="1000"/>
+              </a:spcAft>
+            </a:pPr>
+            <a:r>
+              <a:rPr sz="1050" b="1">
+                <a:solidFill>
+                  <a:srgbClr val="0D3B66"/>
+                </a:solidFill>
+                <a:latin typeface="Consolas"/>
+              </a:rPr>
+              <a:t>[9]  </a:t>
+            </a:r>
+            <a:r>
+              <a:rPr sz="1050">
+                <a:solidFill>
+                  <a:srgbClr val="4A4F58"/>
+                </a:solidFill>
+                <a:latin typeface="Segoe UI"/>
+              </a:rPr>
+              <a:t>S. Es, J. James, L. Espinosa-Anke, and S. Schockaert, “RAGAS: Automated evaluation of retrieval augmented generation,” in Proc. 18th Conf. European Chapter Assoc. Comput. Linguistics: System Demonstrations (EACL), St. Julian’s, Malta, Mar. 2024, pp. 150–158.</a:t>
+            </a:r>
+          </a:p>
+          <a:p>
+            <a:pPr>
+              <a:lnSpc>
+                <a:spcPct val="105000"/>
+              </a:lnSpc>
+              <a:spcAft>
+                <a:spcPts val="1000"/>
+              </a:spcAft>
+            </a:pPr>
+            <a:r>
+              <a:rPr sz="1050" b="1">
+                <a:solidFill>
+                  <a:srgbClr val="0D3B66"/>
+                </a:solidFill>
+                <a:latin typeface="Consolas"/>
+              </a:rPr>
+              <a:t>[10]  </a:t>
+            </a:r>
+            <a:r>
+              <a:rPr sz="1050">
+                <a:solidFill>
+                  <a:srgbClr val="4A4F58"/>
+                </a:solidFill>
+                <a:latin typeface="Segoe UI"/>
+              </a:rPr>
+              <a:t>C. Niu et al., “RAGTruth: A hallucination corpus for developing trustworthy retrieval-augmented language models,” in Proc. 62nd Annual Meeting Assoc. Comput. Linguistics (ACL), Vol. 1: Long Papers, Bangkok, Thailand, Aug. 2024, pp. 10862–10878.</a:t>
+            </a:r>
+          </a:p>
+        </p:txBody>
+      </p:sp>
+      <p:sp>
+        <p:nvSpPr>
+          <p:cNvPr id="8" name="Rectangle 7"/>
           <p:cNvSpPr/>
           <p:nvPr/>
         </p:nvSpPr>
@@ -7351,7 +6902,7 @@
       </p:sp>
       <p:sp>
         <p:nvSpPr>
-          <p:cNvPr id="8" name="TextBox 7"/>
+          <p:cNvPr id="9" name="TextBox 8"/>
           <p:cNvSpPr txBox="1"/>
           <p:nvPr/>
         </p:nvSpPr>

</xml_diff>